<commit_message>
Merged course: apply pilot-batch improvements
- check_course.py: one ★ per K, merged-count consistency, 3–5 key points ≤30 chars, ≤8 legal bases, 3–6 quiz items with answers, real-footage ≤30%
- tools/course/mk_sources.py, mk_source_videos.py (from the pilot writer)
- build_project.py: course-edition workflow.md refers to 来源.tsv and the 说明书 instead of 审查报告
- make_courseware.py: no source-video names in courseware notes
- authoring spec: writing conventions; 实拍 judged per lesson by the four criteria

Co-Authored-By: Claude Opus 5.5 <noreply@anthropic.com>
Claude-Session: https://claude.ai/code/session_019WMG3MqnCR2aBDZNJQpnyX
</commit_message>
<xml_diff>
--- a/course/高校实验室安全/课件/001_课程导学：从规则到风险管理.pptx
+++ b/course/高校实验室安全/课件/001_课程导学：从规则到风险管理.pptx
@@ -529,12 +529,6 @@
               <a:t>学习本课程的目的，是在动手之前就知道“哪里可能出事、怎样防止出事、出了事怎么办”。第一次进入实验室时就要建立这种意识，而不是等到发生险情之后才补课。</a:t>
             </a:r>
           </a:p>
-          <a:p/>
-          <a:p>
-            <a:r>
-              <a:t>来源：合并了 2 个原知识点，最佳讲解取自 CDC Laboratory Safety Series 01（详见 来源.tsv）</a:t>
-            </a:r>
-          </a:p>
         </p:txBody>
       </p:sp>
       <p:sp>
@@ -760,12 +754,6 @@
               <a:t>因此，要把安全要求当作实验方案的一部分来设计和执行，而不是额外的负担。</a:t>
             </a:r>
           </a:p>
-          <a:p/>
-          <a:p>
-            <a:r>
-              <a:t>来源：合并了 1 个原知识点，最佳讲解取自 Acids, Bases &amp; Solvents Safety 12（详见 来源.tsv）</a:t>
-            </a:r>
-          </a:p>
         </p:txBody>
       </p:sp>
       <p:sp>
@@ -841,12 +829,6 @@
               <a:t>实验室是共享空间。一个人的不规范操作，可能伤及隔壁实验台的同学、楼内其他人员乃至周边环境；反过来，别人的疏忽也可能波及你。所以安全不只是“管好自己”，还包括提醒他人、及时报告隐患。</a:t>
             </a:r>
           </a:p>
-          <a:p/>
-          <a:p>
-            <a:r>
-              <a:t>来源：合并了 2 个原知识点，最佳讲解取自 Acids, Bases &amp; Solvents Safety 12（详见 来源.tsv）</a:t>
-            </a:r>
-          </a:p>
         </p:txBody>
       </p:sp>
       <p:sp>
@@ -927,12 +909,6 @@
               <a:t>认识到事故的全部代价，就会明白：在预防上花的时间和经费，是最划算的投入。</a:t>
             </a:r>
           </a:p>
-          <a:p/>
-          <a:p>
-            <a:r>
-              <a:t>来源：合并了 3 个原知识点，最佳讲解取自 Laboratory Ergonomics &amp; RSI 17（详见 来源.tsv）</a:t>
-            </a:r>
-          </a:p>
         </p:txBody>
       </p:sp>
       <p:sp>
@@ -1013,12 +989,6 @@
               <a:t>懂原则的人，在规则没有写到的地方也能做出正确判断；但懂原则不等于可以不守规则——学校和实验室的规定是底线，必须遵守。</a:t>
             </a:r>
           </a:p>
-          <a:p/>
-          <a:p>
-            <a:r>
-              <a:t>来源：合并了 2 个原知识点，最佳讲解取自 ACS College Lab Safety Series 01（详见 来源.tsv）</a:t>
-            </a:r>
-          </a:p>
         </p:txBody>
       </p:sp>
       <p:sp>
@@ -1099,12 +1069,6 @@
               <a:t>对于设备用法、化学品性质、操作步骤等任何拿不准的问题，先问实验室负责人、导师或实验室安全员，弄清楚再做。</a:t>
             </a:r>
           </a:p>
-          <a:p/>
-          <a:p>
-            <a:r>
-              <a:t>来源：合并了 1 个原知识点，最佳讲解取自 Lab Safety Training Series 03（详见 来源.tsv）</a:t>
-            </a:r>
-          </a:p>
         </p:txBody>
       </p:sp>
       <p:sp>
@@ -1180,12 +1144,6 @@
               <a:t>高校实验室安全工作同样遵循这一方针（具体表述以《高等学校实验室安全规范》和本校制度的现行文本为准）。落到每个人身上，就是：实验前做好准备和评估，实验中规范操作，发现隐患及时报告，而不是等出了事再补救。</a:t>
             </a:r>
           </a:p>
-          <a:p/>
-          <a:p>
-            <a:r>
-              <a:t>来源：补充知识点（依据《中华人民共和国安全生产法》和《高等学校实验室安全规范》，原视频未涉及）</a:t>
-            </a:r>
-          </a:p>
         </p:txBody>
       </p:sp>
       <p:sp>
@@ -1264,12 +1222,6 @@
           <a:p>
             <a:r>
               <a:t>学习时要带着问题：我的实验用了哪些物质和设备？可能出什么事？应该怎样防护和应急？把课程内容和自己的实际工作对照起来，才能真正用得上。</a:t>
-            </a:r>
-          </a:p>
-          <a:p/>
-          <a:p>
-            <a:r>
-              <a:t>来源：补充知识点（依据本课程大纲，原视频未涉及）</a:t>
             </a:r>
           </a:p>
         </p:txBody>

</xml_diff>